<commit_message>
feat: implement metadata simplification (CHANGE-001) and source expression syntax (CHANGE-002)
CHANGE-001: Simplify slide metadata to only tags
- Remove section/feature/status/owner fields
- Support @tags, @tag-start, @tag-end in notes
- Implement tag range pairing algorithm with auto-close logic
- Report errors for unmatched tag-start/tag-end

CHANGE-002: Single-line source expression syntax
- Add parse_source_expr() for gitlab[CI/CD]:1-3,5 format
- Support negative page indices (-1, -3--1)
- Add resolve_source_pages() for tag filtering + page resolution
- Update validator for expression-based page validation
</commit_message>
<xml_diff>
--- a/tests/fixtures/with_metadata.pptx
+++ b/tests/fixtures/with_metadata.pptx
@@ -26,11 +26,8 @@
           <a:bodyPr/>
           <a:p>
             <a:r>
-              <a:t>@section: CI/CD
-@feature: Pipeline
-@tags: devops, 自动化
-@status: stable
-@owner: 张三
+              <a:t>@tags: devops, 自动化
+@tag-start: Pipeline
 ---
 备注内容</a:t>
             </a:r>
@@ -58,9 +55,7 @@
           <a:bodyPr/>
           <a:p>
             <a:r>
-              <a:t>@section: CI/CD
-@feature: Runner
-@status: stable
+              <a:t>@tags: 重点
 ---
 第二页备注</a:t>
             </a:r>
@@ -88,8 +83,7 @@
           <a:bodyPr/>
           <a:p>
             <a:r>
-              <a:t>@status: deprecated
-@owner: 李四
+              <a:t>@tag-end: Pipeline
 ---
 过时了</a:t>
             </a:r>

</xml_diff>